<commit_message>
Deck: fold in hackathon evidence (blind-start COBYLA runs, Qiskit re-simulation, 1000-qubit numbers, refinement-depth benchmark)
Amp-Thread-ID: https://ampcode.com/threads/T-01a0805d-dcde-7427-ab00-0cf6a7ee8b26
Co-authored-by: Amp <amp@ampcode.com>
</commit_message>
<xml_diff>
--- a/presentation/MantiQ_Factor_Antenna_Tilt.pptx
+++ b/presentation/MantiQ_Factor_Antenna_Tilt.pptx
@@ -869,7 +869,7 @@
           <a:p>
             <a:r>
               <a:rPr lang="en-US" dirty="0"/>
-              <a:t>This slide keeps the team contribution visible: the hierarchy is theirs, the verified leaf is ours, and they compose.</a:t>
+              <a:t>This slide keeps the team contribution visible: the hierarchy is theirs, the verified leaf is ours, and they compose. The 1000-qubit numbers come from the hackathon deck (slide 13 there).</a:t>
             </a:r>
             <a:endParaRPr lang="en-US" dirty="0"/>
           </a:p>
@@ -6101,7 +6101,7 @@
                           <a:ea typeface="Calibri" pitchFamily="34" charset="-122"/>
                           <a:cs typeface="Calibri" pitchFamily="34" charset="-120"/>
                         </a:rPr>
-                        <a:t>1.9985</a:t>
+                        <a:t>1.9985 (Qiskit statevector of the exported QASM: 1.9985)</a:t>
                       </a:r>
                       <a:endParaRPr lang="en-US" sz="1200" dirty="0">
                         <a:latin typeface="Calibri" charset="0"/>
@@ -6169,7 +6169,7 @@
                           <a:ea typeface="Calibri" pitchFamily="34" charset="-122"/>
                           <a:cs typeface="Calibri" pitchFamily="34" charset="-120"/>
                         </a:rPr>
-                        <a:t>2.06 (run 1), 1.99 (after COBYLA)</a:t>
+                        <a:t>2.02 to 2.06 (4096 shots), 1.99 after COBYLA</a:t>
                       </a:r>
                       <a:endParaRPr lang="en-US" sz="1200" dirty="0">
                         <a:latin typeface="Calibri" charset="0"/>
@@ -7686,7 +7686,7 @@
                 <a:ea typeface="Calibri" pitchFamily="34" charset="-122"/>
                 <a:cs typeface="Calibri" pitchFamily="34" charset="-120"/>
               </a:rPr>
-              <a:t>COBYLA on the simulator did not beat the Wolfram angles in 8 iterations, which is the expected outcome when the hot start is already the exact optimum of the landscape</a:t>
+              <a:t>Blind COBYLA starts on Classiq (hackathon runs): start (0.20, 0.50) stuck at &lt;Cost&gt; 35.5, start (0.02, 0.60) reached only 7.0 after 20 jobs. From the Wolfram angles: 2.0 in the first job, and 8 more iterations found nothing better</a:t>
             </a:r>
             <a:endParaRPr lang="en-US" sz="1350" dirty="0"/>
           </a:p>
@@ -7927,9 +7927,324 @@
           </a:p>
         </p:txBody>
       </p:sp>
+      <p:sp>
+        <p:nvSpPr>
+          <p:cNvPr id="8" name="Shape 6"/>
+          <p:cNvSpPr/>
+          <p:nvPr/>
+        </p:nvSpPr>
+        <p:spPr>
+          <a:xfrm>
+            <a:off x="548640" y="1371600"/>
+            <a:ext cx="3611880" cy="1234440"/>
+          </a:xfrm>
+          <a:prstGeom prst="roundRect">
+            <a:avLst>
+              <a:gd name="adj" fmla="val 5926"/>
+            </a:avLst>
+          </a:prstGeom>
+          <a:solidFill>
+            <a:srgbClr val="0D1330"/>
+          </a:solidFill>
+          <a:ln w="12700">
+            <a:solidFill>
+              <a:srgbClr val="0D1330"/>
+            </a:solidFill>
+            <a:prstDash val="solid"/>
+          </a:ln>
+        </p:spPr>
+      </p:sp>
+      <p:sp>
+        <p:nvSpPr>
+          <p:cNvPr id="9" name="Text 7"/>
+          <p:cNvSpPr/>
+          <p:nvPr/>
+        </p:nvSpPr>
+        <p:spPr>
+          <a:xfrm>
+            <a:off x="548640" y="1481328"/>
+            <a:ext cx="3611880" cy="640080"/>
+          </a:xfrm>
+          <a:prstGeom prst="rect">
+            <a:avLst/>
+          </a:prstGeom>
+          <a:noFill/>
+          <a:ln/>
+        </p:spPr>
+        <p:txBody>
+          <a:bodyPr wrap="square" lIns="0" tIns="0" rIns="0" bIns="0" rtlCol="0" anchor="ctr"/>
+          <a:lstStyle/>
+          <a:p>
+            <a:pPr algn="ctr" indent="0" marL="0">
+              <a:buNone/>
+            </a:pPr>
+            <a:r>
+              <a:rPr lang="en-US" sz="2800" b="1" dirty="0">
+                <a:solidFill>
+                  <a:srgbClr val="F2B632"/>
+                </a:solidFill>
+                <a:latin typeface="Calibri" pitchFamily="34" charset="0"/>
+                <a:ea typeface="Calibri" pitchFamily="34" charset="-122"/>
+                <a:cs typeface="Calibri" pitchFamily="34" charset="-120"/>
+              </a:rPr>
+              <a:t>10^301</a:t>
+            </a:r>
+            <a:endParaRPr lang="en-US" sz="2800" dirty="0"/>
+          </a:p>
+        </p:txBody>
+      </p:sp>
+      <p:sp>
+        <p:nvSpPr>
+          <p:cNvPr id="10" name="Text 8"/>
+          <p:cNvSpPr/>
+          <p:nvPr/>
+        </p:nvSpPr>
+        <p:spPr>
+          <a:xfrm>
+            <a:off x="640080" y="2103120"/>
+            <a:ext cx="3429000" cy="457200"/>
+          </a:xfrm>
+          <a:prstGeom prst="rect">
+            <a:avLst/>
+          </a:prstGeom>
+          <a:noFill/>
+          <a:ln/>
+        </p:spPr>
+        <p:txBody>
+          <a:bodyPr wrap="square" lIns="0" tIns="0" rIns="0" bIns="0" rtlCol="0" anchor="ctr"/>
+          <a:lstStyle/>
+          <a:p>
+            <a:pPr algn="ctr" indent="0" marL="0">
+              <a:buNone/>
+            </a:pPr>
+            <a:r>
+              <a:rPr lang="en-US" sz="1100" dirty="0">
+                <a:solidFill>
+                  <a:srgbClr val="9AA3BD"/>
+                </a:solidFill>
+                <a:latin typeface="Calibri" pitchFamily="34" charset="0"/>
+                <a:ea typeface="Calibri" pitchFamily="34" charset="-122"/>
+                <a:cs typeface="Calibri" pitchFamily="34" charset="-120"/>
+              </a:rPr>
+              <a:t>plans for 500 antennas x 4 tilts (today: 4096)</a:t>
+            </a:r>
+            <a:endParaRPr lang="en-US" sz="1100" dirty="0"/>
+          </a:p>
+        </p:txBody>
+      </p:sp>
+      <p:sp>
+        <p:nvSpPr>
+          <p:cNvPr id="11" name="Shape 9"/>
+          <p:cNvSpPr/>
+          <p:nvPr/>
+        </p:nvSpPr>
+        <p:spPr>
+          <a:xfrm>
+            <a:off x="4297680" y="1371600"/>
+            <a:ext cx="3611880" cy="1234440"/>
+          </a:xfrm>
+          <a:prstGeom prst="roundRect">
+            <a:avLst>
+              <a:gd name="adj" fmla="val 5926"/>
+            </a:avLst>
+          </a:prstGeom>
+          <a:solidFill>
+            <a:srgbClr val="0D1330"/>
+          </a:solidFill>
+          <a:ln w="12700">
+            <a:solidFill>
+              <a:srgbClr val="0D1330"/>
+            </a:solidFill>
+            <a:prstDash val="solid"/>
+          </a:ln>
+        </p:spPr>
+      </p:sp>
+      <p:sp>
+        <p:nvSpPr>
+          <p:cNvPr id="12" name="Text 10"/>
+          <p:cNvSpPr/>
+          <p:nvPr/>
+        </p:nvSpPr>
+        <p:spPr>
+          <a:xfrm>
+            <a:off x="4297680" y="1481328"/>
+            <a:ext cx="3611880" cy="640080"/>
+          </a:xfrm>
+          <a:prstGeom prst="rect">
+            <a:avLst/>
+          </a:prstGeom>
+          <a:noFill/>
+          <a:ln/>
+        </p:spPr>
+        <p:txBody>
+          <a:bodyPr wrap="square" lIns="0" tIns="0" rIns="0" bIns="0" rtlCol="0" anchor="ctr"/>
+          <a:lstStyle/>
+          <a:p>
+            <a:pPr algn="ctr" indent="0" marL="0">
+              <a:buNone/>
+            </a:pPr>
+            <a:r>
+              <a:rPr lang="en-US" sz="2800" b="1" dirty="0">
+                <a:solidFill>
+                  <a:srgbClr val="F2B632"/>
+                </a:solidFill>
+                <a:latin typeface="Calibri" pitchFamily="34" charset="0"/>
+                <a:ea typeface="Calibri" pitchFamily="34" charset="-122"/>
+                <a:cs typeface="Calibri" pitchFamily="34" charset="-120"/>
+              </a:rPr>
+              <a:t>about 45 qubits</a:t>
+            </a:r>
+            <a:endParaRPr lang="en-US" sz="2800" dirty="0"/>
+          </a:p>
+        </p:txBody>
+      </p:sp>
+      <p:sp>
+        <p:nvSpPr>
+          <p:cNvPr id="13" name="Text 11"/>
+          <p:cNvSpPr/>
+          <p:nvPr/>
+        </p:nvSpPr>
+        <p:spPr>
+          <a:xfrm>
+            <a:off x="4389120" y="2103120"/>
+            <a:ext cx="3429000" cy="457200"/>
+          </a:xfrm>
+          <a:prstGeom prst="rect">
+            <a:avLst/>
+          </a:prstGeom>
+          <a:noFill/>
+          <a:ln/>
+        </p:spPr>
+        <p:txBody>
+          <a:bodyPr wrap="square" lIns="0" tIns="0" rIns="0" bIns="0" rtlCol="0" anchor="ctr"/>
+          <a:lstStyle/>
+          <a:p>
+            <a:pPr algn="ctr" indent="0" marL="0">
+              <a:buNone/>
+            </a:pPr>
+            <a:r>
+              <a:rPr lang="en-US" sz="1100" dirty="0">
+                <a:solidFill>
+                  <a:srgbClr val="9AA3BD"/>
+                </a:solidFill>
+                <a:latin typeface="Calibri" pitchFamily="34" charset="0"/>
+                <a:ea typeface="Calibri" pitchFamily="34" charset="-122"/>
+                <a:cs typeface="Calibri" pitchFamily="34" charset="-120"/>
+              </a:rPr>
+              <a:t>ceiling of exact statevector simulation (50 q = 18 PB)</a:t>
+            </a:r>
+            <a:endParaRPr lang="en-US" sz="1100" dirty="0"/>
+          </a:p>
+        </p:txBody>
+      </p:sp>
+      <p:sp>
+        <p:nvSpPr>
+          <p:cNvPr id="14" name="Shape 12"/>
+          <p:cNvSpPr/>
+          <p:nvPr/>
+        </p:nvSpPr>
+        <p:spPr>
+          <a:xfrm>
+            <a:off x="8046720" y="1371600"/>
+            <a:ext cx="3749040" cy="1234440"/>
+          </a:xfrm>
+          <a:prstGeom prst="roundRect">
+            <a:avLst>
+              <a:gd name="adj" fmla="val 5926"/>
+            </a:avLst>
+          </a:prstGeom>
+          <a:solidFill>
+            <a:srgbClr val="0D1330"/>
+          </a:solidFill>
+          <a:ln w="12700">
+            <a:solidFill>
+              <a:srgbClr val="0D1330"/>
+            </a:solidFill>
+            <a:prstDash val="solid"/>
+          </a:ln>
+        </p:spPr>
+      </p:sp>
+      <p:sp>
+        <p:nvSpPr>
+          <p:cNvPr id="15" name="Text 13"/>
+          <p:cNvSpPr/>
+          <p:nvPr/>
+        </p:nvSpPr>
+        <p:spPr>
+          <a:xfrm>
+            <a:off x="8046720" y="1481328"/>
+            <a:ext cx="3749040" cy="640080"/>
+          </a:xfrm>
+          <a:prstGeom prst="rect">
+            <a:avLst/>
+          </a:prstGeom>
+          <a:noFill/>
+          <a:ln/>
+        </p:spPr>
+        <p:txBody>
+          <a:bodyPr wrap="square" lIns="0" tIns="0" rIns="0" bIns="0" rtlCol="0" anchor="ctr"/>
+          <a:lstStyle/>
+          <a:p>
+            <a:pPr algn="ctr" indent="0" marL="0">
+              <a:buNone/>
+            </a:pPr>
+            <a:r>
+              <a:rPr lang="en-US" sz="2800" b="1" dirty="0">
+                <a:solidFill>
+                  <a:srgbClr val="F2B632"/>
+                </a:solidFill>
+                <a:latin typeface="Calibri" pitchFamily="34" charset="0"/>
+                <a:ea typeface="Calibri" pitchFamily="34" charset="-122"/>
+                <a:cs typeface="Calibri" pitchFamily="34" charset="-120"/>
+              </a:rPr>
+              <a:t>about 13,000 CX</a:t>
+            </a:r>
+            <a:endParaRPr lang="en-US" sz="2800" dirty="0"/>
+          </a:p>
+        </p:txBody>
+      </p:sp>
+      <p:sp>
+        <p:nvSpPr>
+          <p:cNvPr id="16" name="Text 14"/>
+          <p:cNvSpPr/>
+          <p:nvPr/>
+        </p:nvSpPr>
+        <p:spPr>
+          <a:xfrm>
+            <a:off x="8138160" y="2103120"/>
+            <a:ext cx="3566160" cy="457200"/>
+          </a:xfrm>
+          <a:prstGeom prst="rect">
+            <a:avLst/>
+          </a:prstGeom>
+          <a:noFill/>
+          <a:ln/>
+        </p:spPr>
+        <p:txBody>
+          <a:bodyPr wrap="square" lIns="0" tIns="0" rIns="0" bIns="0" rtlCol="0" anchor="ctr"/>
+          <a:lstStyle/>
+          <a:p>
+            <a:pPr algn="ctr" indent="0" marL="0">
+              <a:buNone/>
+            </a:pPr>
+            <a:r>
+              <a:rPr lang="en-US" sz="1100" dirty="0">
+                <a:solidFill>
+                  <a:srgbClr val="9AA3BD"/>
+                </a:solidFill>
+                <a:latin typeface="Calibri" pitchFamily="34" charset="0"/>
+                <a:ea typeface="Calibri" pitchFamily="34" charset="-122"/>
+                <a:cs typeface="Calibri" pitchFamily="34" charset="-120"/>
+              </a:rPr>
+              <a:t>one QAOA layer at 1000 qubits, still 2-local</a:t>
+            </a:r>
+            <a:endParaRPr lang="en-US" sz="1100" dirty="0"/>
+          </a:p>
+        </p:txBody>
+      </p:sp>
       <p:pic>
         <p:nvPicPr>
-          <p:cNvPr id="8" name="Image 0" descr="C:\Projects\mantiq-factor-antenna-tilt\charts\group_benchmark_bars.png">    </p:cNvPr>
+          <p:cNvPr id="17" name="Image 0" descr="C:\Projects\mantiq-factor-antenna-tilt\charts\group_benchmark_depth.png">    </p:cNvPr>
           <p:cNvPicPr>
             <a:picLocks noChangeAspect="1"/>
           </p:cNvPicPr>
@@ -7943,8 +8258,8 @@
         </p:blipFill>
         <p:spPr>
           <a:xfrm>
-            <a:off x="548640" y="1417320"/>
-            <a:ext cx="5486400" cy="2715768"/>
+            <a:off x="548640" y="2788920"/>
+            <a:ext cx="4480560" cy="2578608"/>
           </a:xfrm>
           <a:prstGeom prst="rect">
             <a:avLst/>
@@ -7953,14 +8268,14 @@
       </p:pic>
       <p:sp>
         <p:nvSpPr>
-          <p:cNvPr id="9" name="Text 6"/>
-          <p:cNvSpPr/>
-          <p:nvPr/>
-        </p:nvSpPr>
-        <p:spPr>
-          <a:xfrm>
-            <a:off x="548640" y="4160520"/>
-            <a:ext cx="5577840" cy="365760"/>
+          <p:cNvPr id="18" name="Text 15"/>
+          <p:cNvSpPr/>
+          <p:nvPr/>
+        </p:nvSpPr>
+        <p:spPr>
+          <a:xfrm>
+            <a:off x="548640" y="5440680"/>
+            <a:ext cx="4937760" cy="365760"/>
           </a:xfrm>
           <a:prstGeom prst="rect">
             <a:avLst/>
@@ -7984,7 +8299,7 @@
                 <a:ea typeface="Calibri" pitchFamily="34" charset="-122"/>
                 <a:cs typeface="Calibri" pitchFamily="34" charset="-120"/>
               </a:rPr>
-              <a:t>Team benchmark on the 48-region toy network: one plan for all 1.379 (1 call), k-means hierarchy + QAOA 1.547 (10 calls), one job per region 1.838 (48 calls).</a:t>
+              <a:t>Team benchmark, 48-region toy network: refinement 5 -&gt; 21 groups. Cycle 3 (13 groups, 13 QAOA jobs) reaches 1.75 = 95% of the per-region ceiling 1.838 (48 jobs); one plan for all gives 1.379.</a:t>
             </a:r>
             <a:endParaRPr lang="en-US" sz="1050" dirty="0"/>
           </a:p>
@@ -7992,14 +8307,14 @@
       </p:sp>
       <p:sp>
         <p:nvSpPr>
-          <p:cNvPr id="10" name="Text 7"/>
-          <p:cNvSpPr/>
-          <p:nvPr/>
-        </p:nvSpPr>
-        <p:spPr>
-          <a:xfrm>
-            <a:off x="6309360" y="1417320"/>
-            <a:ext cx="5486400" cy="4572000"/>
+          <p:cNvPr id="19" name="Text 16"/>
+          <p:cNvSpPr/>
+          <p:nvPr/>
+        </p:nvSpPr>
+        <p:spPr>
+          <a:xfrm>
+            <a:off x="5669280" y="2788920"/>
+            <a:ext cx="6126480" cy="3200400"/>
           </a:xfrm>
           <a:prstGeom prst="rect">
             <a:avLst/>
@@ -8019,7 +8334,7 @@
               <a:buChar char="▸"/>
             </a:pPr>
             <a:r>
-              <a:rPr lang="en-US" sz="1300" dirty="0">
+              <a:rPr lang="en-US" sz="1200" dirty="0">
                 <a:solidFill>
                   <a:srgbClr val="F4F6FB"/>
                 </a:solidFill>
@@ -8027,9 +8342,9 @@
                 <a:ea typeface="Calibri" pitchFamily="34" charset="-122"/>
                 <a:cs typeface="Calibri" pitchFamily="34" charset="-120"/>
               </a:rPr>
-              <a:t>Network -&gt; 5 groups -&gt; 25 -&gt; 125: k-means on region feature vectors, one QAOA job per group, recursive refinement where the utility gain is worth it</a:t>
-            </a:r>
-            <a:endParaRPr lang="en-US" sz="1300" dirty="0"/>
+              <a:t>Network -&gt; 5 groups -&gt; 25 -&gt; 125: k-means on region feature vectors, one QAOA job per group, refine where the utility gain is worth it. Our 12-qubit problem is one job in that tree</a:t>
+            </a:r>
+            <a:endParaRPr lang="en-US" sz="1200" dirty="0"/>
           </a:p>
           <a:p>
             <a:pPr marL="342900" indent="-342900">
@@ -8040,7 +8355,7 @@
               <a:buChar char="▸"/>
             </a:pPr>
             <a:r>
-              <a:rPr lang="en-US" sz="1300" dirty="0">
+              <a:rPr lang="en-US" sz="1200" dirty="0">
                 <a:solidFill>
                   <a:srgbClr val="F4F6FB"/>
                 </a:solidFill>
@@ -8048,9 +8363,9 @@
                 <a:ea typeface="Calibri" pitchFamily="34" charset="-122"/>
                 <a:cs typeface="Calibri" pitchFamily="34" charset="-120"/>
               </a:rPr>
-              <a:t>Our 12-qubit problem is one job in that tree; 2 qubits per antenna means a group of n antennas needs 2n qubits, still 2-local</a:t>
-            </a:r>
-            <a:endParaRPr lang="en-US" sz="1300" dirty="0"/>
+              <a:t>Best non-quantum tools at 1000 qubits: brute force 10^283 s at exascale; exact QUBO solvers run hours to days without certifying; annealing and tabu give a good plan in minutes with no guarantee (1.833 vs 1.838 on the toy benchmark). Nobody can simulate QAOA past about 48 qubits</a:t>
+            </a:r>
+            <a:endParaRPr lang="en-US" sz="1200" dirty="0"/>
           </a:p>
           <a:p>
             <a:pPr marL="342900" indent="-342900">
@@ -8061,7 +8376,7 @@
               <a:buChar char="▸"/>
             </a:pPr>
             <a:r>
-              <a:rPr lang="en-US" sz="1300" dirty="0">
+              <a:rPr lang="en-US" sz="1200" dirty="0">
                 <a:solidFill>
                   <a:srgbClr val="F4F6FB"/>
                 </a:solidFill>
@@ -8069,9 +8384,9 @@
                 <a:ea typeface="Calibri" pitchFamily="34" charset="-122"/>
                 <a:cs typeface="Calibri" pitchFamily="34" charset="-120"/>
               </a:rPr>
-              <a:t>At 500 antennas (1000 qubits): 4^500 plans, exact enumeration and statevector simulation are impossible; the best classical tools are heuristics (simulated annealing, tabu, QUBO solvers) with no optimality certificate</a:t>
-            </a:r>
-            <a:endParaRPr lang="en-US" sz="1300" dirty="0"/>
+              <a:t>A real 1000-qubit gate-based machine: physical qubits exist (IBM Condor 1121, Atom Computing 1200), but 13,000 CX at 99.9% fidelity means about 13 errors per shot, so the run must be error-corrected (2,000 to 100,000 physical qubits; roadmaps 2028 to 2030)</a:t>
+            </a:r>
+            <a:endParaRPr lang="en-US" sz="1200" dirty="0"/>
           </a:p>
           <a:p>
             <a:pPr marL="342900" indent="-342900">
@@ -8082,7 +8397,7 @@
               <a:buChar char="▸"/>
             </a:pPr>
             <a:r>
-              <a:rPr lang="en-US" sz="1300" dirty="0">
+              <a:rPr lang="en-US" sz="1200" dirty="0">
                 <a:solidFill>
                   <a:srgbClr val="F4F6FB"/>
                 </a:solidFill>
@@ -8090,9 +8405,9 @@
                 <a:ea typeface="Calibri" pitchFamily="34" charset="-122"/>
                 <a:cs typeface="Calibri" pitchFamily="34" charset="-120"/>
               </a:rPr>
-              <a:t>On a 1000-qubit gate-based machine the same Qmod compiles unchanged; QAOA depth grows linearly in the number of interfering pairs, not in the number of plans</a:t>
-            </a:r>
-            <a:endParaRPr lang="en-US" sz="1300" dirty="0"/>
+              <a:t>Once available: depth ~10^2 per layer, 10^4 shots x 20 iterations = seconds to minutes; the Wolfram hot start cuts the iterations. Same Qmod, Classiq synthesizes for the target; only the backend changes</a:t>
+            </a:r>
+            <a:endParaRPr lang="en-US" sz="1200" dirty="0"/>
           </a:p>
           <a:p>
             <a:pPr marL="342900" indent="-342900">
@@ -8103,7 +8418,7 @@
               <a:buChar char="▸"/>
             </a:pPr>
             <a:r>
-              <a:rPr lang="en-US" sz="1300" dirty="0">
+              <a:rPr lang="en-US" sz="1200" dirty="0">
                 <a:solidFill>
                   <a:srgbClr val="F4F6FB"/>
                 </a:solidFill>
@@ -8111,9 +8426,9 @@
                 <a:ea typeface="Calibri" pitchFamily="34" charset="-122"/>
                 <a:cs typeface="Calibri" pitchFamily="34" charset="-120"/>
               </a:rPr>
-              <a:t>What carries over from the small case: the encoding proof, the 2-locality, and the hot-start habit (train angles on a small exact instance, transfer to the large one)</a:t>
-            </a:r>
-            <a:endParaRPr lang="en-US" sz="1300" dirty="0"/>
+              <a:t>What carries over unchanged: the encoding proof, the 2-locality, the hot-start habit (train angles on a small exact instance, transfer to the large one)</a:t>
+            </a:r>
+            <a:endParaRPr lang="en-US" sz="1200" dirty="0"/>
           </a:p>
         </p:txBody>
       </p:sp>
@@ -9999,7 +10314,7 @@
                 <a:ea typeface="Calibri" pitchFamily="34" charset="-122"/>
                 <a:cs typeface="Calibri" pitchFamily="34" charset="-120"/>
               </a:rPr>
-              <a:t>Wolfram found the angles exactly; the Classiq run confirmed them in one shot and COBYLA had nothing left to do. No blind parameter search on a paid simulator.</a:t>
+              <a:t>Wolfram found the angles exactly; the Classiq run confirmed them in one shot and COBYLA had nothing left to do. Blind starts on the simulator got stuck at 35.5 or reached only 7.0 after 20 jobs: shot noise hides the gradient.</a:t>
             </a:r>
             <a:endParaRPr lang="en-US" sz="1400" dirty="0"/>
           </a:p>

</xml_diff>